<commit_message>
Add Slide 13: 3-member team role allocation and work distribution
</commit_message>
<xml_diff>
--- a/Explainable_Tomato_Leaf_Disease_Detection_Presentation.pptx
+++ b/Explainable_Tomato_Leaf_Disease_Detection_Presentation.pptx
@@ -17,6 +17,7 @@
     <p:sldId id="265" r:id="rId16"/>
     <p:sldId id="266" r:id="rId17"/>
     <p:sldId id="267" r:id="rId18"/>
+    <p:sldId id="268" r:id="rId19"/>
   </p:sldIdLst>
   <p:sldSz cx="12191695" cy="6858000" type="screen4x3"/>
   <p:notesSz cx="6858000" cy="9144000"/>
@@ -4691,49 +4692,902 @@
               <a:t>Future Extensions</a:t>
             </a:r>
           </a:p>
-          <a:p>
-            <a:pPr>
-              <a:spcBef>
-                <a:spcPts val="1200"/>
-              </a:spcBef>
-              <a:defRPr sz="1300">
+        </p:txBody>
+      </p:sp>
+    </p:spTree>
+  </p:cSld>
+  <p:clrMapOvr>
+    <a:masterClrMapping/>
+  </p:clrMapOvr>
+</p:sld>
+</file>
+
+<file path=ppt/slides/slide13.xml><?xml version="1.0" encoding="utf-8"?>
+<p:sld xmlns:a="http://schemas.openxmlformats.org/drawingml/2006/main" xmlns:p="http://schemas.openxmlformats.org/presentationml/2006/main" xmlns:r="http://schemas.openxmlformats.org/officeDocument/2006/relationships">
+  <p:cSld>
+    <p:spTree>
+      <p:nvGrpSpPr>
+        <p:cNvPr id="1" name=""/>
+        <p:cNvGrpSpPr/>
+        <p:nvPr/>
+      </p:nvGrpSpPr>
+      <p:grpSpPr/>
+      <p:sp>
+        <p:nvSpPr>
+          <p:cNvPr id="2" name="Rectangle 1"/>
+          <p:cNvSpPr/>
+          <p:nvPr/>
+        </p:nvSpPr>
+        <p:spPr>
+          <a:xfrm>
+            <a:off x="0" y="0"/>
+            <a:ext cx="12191695" cy="6858000"/>
+          </a:xfrm>
+          <a:prstGeom prst="rect">
+            <a:avLst/>
+          </a:prstGeom>
+          <a:solidFill>
+            <a:srgbClr val="F7FBF7"/>
+          </a:solidFill>
+          <a:ln>
+            <a:noFill/>
+          </a:ln>
+        </p:spPr>
+        <p:style>
+          <a:lnRef idx="1">
+            <a:schemeClr val="accent1"/>
+          </a:lnRef>
+          <a:fillRef idx="3">
+            <a:schemeClr val="accent1"/>
+          </a:fillRef>
+          <a:effectRef idx="2">
+            <a:schemeClr val="accent1"/>
+          </a:effectRef>
+          <a:fontRef idx="minor">
+            <a:schemeClr val="lt1"/>
+          </a:fontRef>
+        </p:style>
+        <p:txBody>
+          <a:bodyPr rtlCol="0" anchor="ctr"/>
+          <a:lstStyle/>
+          <a:p>
+            <a:pPr algn="ctr"/>
+          </a:p>
+        </p:txBody>
+      </p:sp>
+      <p:sp>
+        <p:nvSpPr>
+          <p:cNvPr id="3" name="TextBox 2"/>
+          <p:cNvSpPr txBox="1"/>
+          <p:nvPr/>
+        </p:nvSpPr>
+        <p:spPr>
+          <a:xfrm>
+            <a:off x="731520" y="411480"/>
+            <a:ext cx="10728655" cy="1005840"/>
+          </a:xfrm>
+          <a:prstGeom prst="rect">
+            <a:avLst/>
+          </a:prstGeom>
+          <a:noFill/>
+        </p:spPr>
+        <p:txBody>
+          <a:bodyPr wrap="square" lIns="0" tIns="0" rIns="0" bIns="0">
+            <a:spAutoFit/>
+          </a:bodyPr>
+          <a:lstStyle/>
+          <a:p>
+            <a:pPr>
+              <a:defRPr sz="1100" b="1">
+                <a:solidFill>
+                  <a:srgbClr val="1B5E3C"/>
+                </a:solidFill>
+              </a:defRPr>
+            </a:pPr>
+            <a:r>
+              <a:t>TEAM GREEN TECH · PROJECT EXECUTION</a:t>
+            </a:r>
+          </a:p>
+          <a:p>
+            <a:pPr>
+              <a:spcBef>
+                <a:spcPts val="300"/>
+              </a:spcBef>
+              <a:defRPr sz="2400" b="1">
+                <a:solidFill>
+                  <a:srgbClr val="103324"/>
+                </a:solidFill>
+              </a:defRPr>
+            </a:pPr>
+            <a:r>
+              <a:t>Work Distribution &amp; Member Role Allocation</a:t>
+            </a:r>
+          </a:p>
+        </p:txBody>
+      </p:sp>
+      <p:sp>
+        <p:nvSpPr>
+          <p:cNvPr id="4" name="Rectangle 3"/>
+          <p:cNvSpPr/>
+          <p:nvPr/>
+        </p:nvSpPr>
+        <p:spPr>
+          <a:xfrm>
+            <a:off x="731520" y="1371600"/>
+            <a:ext cx="10728655" cy="18288"/>
+          </a:xfrm>
+          <a:prstGeom prst="rect">
+            <a:avLst/>
+          </a:prstGeom>
+          <a:solidFill>
+            <a:srgbClr val="D7E6DC"/>
+          </a:solidFill>
+          <a:ln>
+            <a:noFill/>
+          </a:ln>
+        </p:spPr>
+        <p:style>
+          <a:lnRef idx="1">
+            <a:schemeClr val="accent1"/>
+          </a:lnRef>
+          <a:fillRef idx="3">
+            <a:schemeClr val="accent1"/>
+          </a:fillRef>
+          <a:effectRef idx="2">
+            <a:schemeClr val="accent1"/>
+          </a:effectRef>
+          <a:fontRef idx="minor">
+            <a:schemeClr val="lt1"/>
+          </a:fontRef>
+        </p:style>
+        <p:txBody>
+          <a:bodyPr rtlCol="0" anchor="ctr"/>
+          <a:lstStyle/>
+          <a:p>
+            <a:pPr algn="ctr"/>
+          </a:p>
+        </p:txBody>
+      </p:sp>
+      <p:sp>
+        <p:nvSpPr>
+          <p:cNvPr id="5" name="Rounded Rectangle 4"/>
+          <p:cNvSpPr/>
+          <p:nvPr/>
+        </p:nvSpPr>
+        <p:spPr>
+          <a:xfrm>
+            <a:off x="731520" y="1645920"/>
+            <a:ext cx="3383280" cy="4663440"/>
+          </a:xfrm>
+          <a:prstGeom prst="roundRect">
+            <a:avLst/>
+          </a:prstGeom>
+          <a:solidFill>
+            <a:srgbClr val="FFFFFF"/>
+          </a:solidFill>
+          <a:ln w="12700">
+            <a:solidFill>
+              <a:srgbClr val="D7E6DC"/>
+            </a:solidFill>
+          </a:ln>
+        </p:spPr>
+        <p:style>
+          <a:lnRef idx="1">
+            <a:schemeClr val="accent1"/>
+          </a:lnRef>
+          <a:fillRef idx="3">
+            <a:schemeClr val="accent1"/>
+          </a:fillRef>
+          <a:effectRef idx="2">
+            <a:schemeClr val="accent1"/>
+          </a:effectRef>
+          <a:fontRef idx="minor">
+            <a:schemeClr val="lt1"/>
+          </a:fontRef>
+        </p:style>
+        <p:txBody>
+          <a:bodyPr rtlCol="0" anchor="ctr"/>
+          <a:lstStyle/>
+          <a:p>
+            <a:pPr algn="ctr"/>
+          </a:p>
+        </p:txBody>
+      </p:sp>
+      <p:sp>
+        <p:nvSpPr>
+          <p:cNvPr id="6" name="Rounded Rectangle 5"/>
+          <p:cNvSpPr/>
+          <p:nvPr/>
+        </p:nvSpPr>
+        <p:spPr>
+          <a:xfrm>
+            <a:off x="731520" y="1645920"/>
+            <a:ext cx="3383280" cy="822960"/>
+          </a:xfrm>
+          <a:prstGeom prst="roundRect">
+            <a:avLst/>
+          </a:prstGeom>
+          <a:solidFill>
+            <a:srgbClr val="1B5E3C"/>
+          </a:solidFill>
+          <a:ln>
+            <a:noFill/>
+          </a:ln>
+        </p:spPr>
+        <p:style>
+          <a:lnRef idx="1">
+            <a:schemeClr val="accent1"/>
+          </a:lnRef>
+          <a:fillRef idx="3">
+            <a:schemeClr val="accent1"/>
+          </a:fillRef>
+          <a:effectRef idx="2">
+            <a:schemeClr val="accent1"/>
+          </a:effectRef>
+          <a:fontRef idx="minor">
+            <a:schemeClr val="lt1"/>
+          </a:fontRef>
+        </p:style>
+        <p:txBody>
+          <a:bodyPr rtlCol="0" anchor="ctr"/>
+          <a:lstStyle/>
+          <a:p>
+            <a:pPr algn="ctr"/>
+          </a:p>
+        </p:txBody>
+      </p:sp>
+      <p:sp>
+        <p:nvSpPr>
+          <p:cNvPr id="7" name="TextBox 6"/>
+          <p:cNvSpPr txBox="1"/>
+          <p:nvPr/>
+        </p:nvSpPr>
+        <p:spPr>
+          <a:xfrm>
+            <a:off x="822960" y="1719072"/>
+            <a:ext cx="3200400" cy="365760"/>
+          </a:xfrm>
+          <a:prstGeom prst="rect">
+            <a:avLst/>
+          </a:prstGeom>
+          <a:noFill/>
+        </p:spPr>
+        <p:txBody>
+          <a:bodyPr wrap="none">
+            <a:spAutoFit/>
+          </a:bodyPr>
+          <a:lstStyle/>
+          <a:p>
+            <a:pPr algn="ctr">
+              <a:defRPr sz="1200" b="1">
+                <a:solidFill>
+                  <a:srgbClr val="FFFFFF"/>
+                </a:solidFill>
+              </a:defRPr>
+            </a:pPr>
+            <a:r>
+              <a:t>Member 1 · AI/ML &amp; Data Lead</a:t>
+            </a:r>
+          </a:p>
+          <a:p>
+            <a:pPr algn="ctr">
+              <a:defRPr sz="1000">
+                <a:solidFill>
+                  <a:srgbClr val="E6F5EB"/>
+                </a:solidFill>
+              </a:defRPr>
+            </a:pPr>
+            <a:r>
+              <a:t>Data &amp; Model Engineering</a:t>
+            </a:r>
+          </a:p>
+        </p:txBody>
+      </p:sp>
+      <p:sp>
+        <p:nvSpPr>
+          <p:cNvPr id="8" name="TextBox 7"/>
+          <p:cNvSpPr txBox="1"/>
+          <p:nvPr/>
+        </p:nvSpPr>
+        <p:spPr>
+          <a:xfrm>
+            <a:off x="868680" y="2606040"/>
+            <a:ext cx="3108960" cy="3566160"/>
+          </a:xfrm>
+          <a:prstGeom prst="rect">
+            <a:avLst/>
+          </a:prstGeom>
+          <a:noFill/>
+        </p:spPr>
+        <p:txBody>
+          <a:bodyPr wrap="square">
+            <a:spAutoFit/>
+          </a:bodyPr>
+          <a:lstStyle/>
+          <a:p>
+            <a:pPr>
+              <a:spcBef>
+                <a:spcPts val="600"/>
+              </a:spcBef>
+              <a:defRPr sz="1100">
                 <a:solidFill>
                   <a:srgbClr val="123726"/>
                 </a:solidFill>
               </a:defRPr>
             </a:pPr>
             <a:r>
-              <a:t>🚀 Drone Multi-Spectral Imaging: Scaling from single-leaf photographs to autonomous UAV aerial orchard scouting.</a:t>
-            </a:r>
-          </a:p>
-          <a:p>
-            <a:pPr>
-              <a:spcBef>
-                <a:spcPts val="1200"/>
-              </a:spcBef>
-              <a:defRPr sz="1300">
+              <a:t>✓ Modules: data.py, model.py, train.py, config.py</a:t>
+            </a:r>
+          </a:p>
+          <a:p>
+            <a:pPr>
+              <a:spcBef>
+                <a:spcPts val="600"/>
+              </a:spcBef>
+              <a:defRPr sz="1100">
                 <a:solidFill>
                   <a:srgbClr val="123726"/>
                 </a:solidFill>
               </a:defRPr>
             </a:pPr>
             <a:r>
-              <a:t>🚀 Offline Mobile Application: Quantized INT8 MobileNetV3 models running offline on Android farm devices without internet.</a:t>
-            </a:r>
-          </a:p>
-          <a:p>
-            <a:pPr>
-              <a:spcBef>
-                <a:spcPts val="1200"/>
-              </a:spcBef>
-              <a:defRPr sz="1300">
+              <a:t>✓ Dataset ingestion &amp; stratified 80/20 train/validation splitting</a:t>
+            </a:r>
+          </a:p>
+          <a:p>
+            <a:pPr>
+              <a:spcBef>
+                <a:spcPts val="600"/>
+              </a:spcBef>
+              <a:defRPr sz="1100">
                 <a:solidFill>
                   <a:srgbClr val="123726"/>
                 </a:solidFill>
               </a:defRPr>
             </a:pPr>
             <a:r>
-              <a:t>🚀 Cross-Crop Solanaceae Expansion: Transferring pretrained weights to eggplants, potatoes, and peppers.</a:t>
+              <a:t>✓ Data augmentations: flips, rotations, ImageNet normalization</a:t>
+            </a:r>
+          </a:p>
+          <a:p>
+            <a:pPr>
+              <a:spcBef>
+                <a:spcPts val="600"/>
+              </a:spcBef>
+              <a:defRPr sz="1100">
+                <a:solidFill>
+                  <a:srgbClr val="123726"/>
+                </a:solidFill>
+              </a:defRPr>
+            </a:pPr>
+            <a:r>
+              <a:t>✓ Multi-architecture CNN backbones (EfficientNet, ResNet, MobileNet)</a:t>
+            </a:r>
+          </a:p>
+          <a:p>
+            <a:pPr>
+              <a:spcBef>
+                <a:spcPts val="600"/>
+              </a:spcBef>
+              <a:defRPr sz="1100">
+                <a:solidFill>
+                  <a:srgbClr val="123726"/>
+                </a:solidFill>
+              </a:defRPr>
+            </a:pPr>
+            <a:r>
+              <a:t>✓ Model training engine with AdamW, lr scheduling, and checkpointing</a:t>
+            </a:r>
+          </a:p>
+          <a:p>
+            <a:pPr>
+              <a:spcBef>
+                <a:spcPts val="600"/>
+              </a:spcBef>
+              <a:defRPr sz="1100">
+                <a:solidFill>
+                  <a:srgbClr val="123726"/>
+                </a:solidFill>
+              </a:defRPr>
+            </a:pPr>
+            <a:r>
+              <a:t>✓ Presentation Delivery: Slides 2, 4, 5 (Problem, Taxonomy, Model)</a:t>
+            </a:r>
+          </a:p>
+        </p:txBody>
+      </p:sp>
+      <p:sp>
+        <p:nvSpPr>
+          <p:cNvPr id="9" name="Rounded Rectangle 8"/>
+          <p:cNvSpPr/>
+          <p:nvPr/>
+        </p:nvSpPr>
+        <p:spPr>
+          <a:xfrm>
+            <a:off x="4398264" y="1645920"/>
+            <a:ext cx="3383280" cy="4663440"/>
+          </a:xfrm>
+          <a:prstGeom prst="roundRect">
+            <a:avLst/>
+          </a:prstGeom>
+          <a:solidFill>
+            <a:srgbClr val="FFFFFF"/>
+          </a:solidFill>
+          <a:ln w="12700">
+            <a:solidFill>
+              <a:srgbClr val="D7E6DC"/>
+            </a:solidFill>
+          </a:ln>
+        </p:spPr>
+        <p:style>
+          <a:lnRef idx="1">
+            <a:schemeClr val="accent1"/>
+          </a:lnRef>
+          <a:fillRef idx="3">
+            <a:schemeClr val="accent1"/>
+          </a:fillRef>
+          <a:effectRef idx="2">
+            <a:schemeClr val="accent1"/>
+          </a:effectRef>
+          <a:fontRef idx="minor">
+            <a:schemeClr val="lt1"/>
+          </a:fontRef>
+        </p:style>
+        <p:txBody>
+          <a:bodyPr rtlCol="0" anchor="ctr"/>
+          <a:lstStyle/>
+          <a:p>
+            <a:pPr algn="ctr"/>
+          </a:p>
+        </p:txBody>
+      </p:sp>
+      <p:sp>
+        <p:nvSpPr>
+          <p:cNvPr id="10" name="Rounded Rectangle 9"/>
+          <p:cNvSpPr/>
+          <p:nvPr/>
+        </p:nvSpPr>
+        <p:spPr>
+          <a:xfrm>
+            <a:off x="4398264" y="1645920"/>
+            <a:ext cx="3383280" cy="822960"/>
+          </a:xfrm>
+          <a:prstGeom prst="roundRect">
+            <a:avLst/>
+          </a:prstGeom>
+          <a:solidFill>
+            <a:srgbClr val="E67E22"/>
+          </a:solidFill>
+          <a:ln>
+            <a:noFill/>
+          </a:ln>
+        </p:spPr>
+        <p:style>
+          <a:lnRef idx="1">
+            <a:schemeClr val="accent1"/>
+          </a:lnRef>
+          <a:fillRef idx="3">
+            <a:schemeClr val="accent1"/>
+          </a:fillRef>
+          <a:effectRef idx="2">
+            <a:schemeClr val="accent1"/>
+          </a:effectRef>
+          <a:fontRef idx="minor">
+            <a:schemeClr val="lt1"/>
+          </a:fontRef>
+        </p:style>
+        <p:txBody>
+          <a:bodyPr rtlCol="0" anchor="ctr"/>
+          <a:lstStyle/>
+          <a:p>
+            <a:pPr algn="ctr"/>
+          </a:p>
+        </p:txBody>
+      </p:sp>
+      <p:sp>
+        <p:nvSpPr>
+          <p:cNvPr id="11" name="TextBox 10"/>
+          <p:cNvSpPr txBox="1"/>
+          <p:nvPr/>
+        </p:nvSpPr>
+        <p:spPr>
+          <a:xfrm>
+            <a:off x="4489704" y="1719072"/>
+            <a:ext cx="3200400" cy="365760"/>
+          </a:xfrm>
+          <a:prstGeom prst="rect">
+            <a:avLst/>
+          </a:prstGeom>
+          <a:noFill/>
+        </p:spPr>
+        <p:txBody>
+          <a:bodyPr wrap="none">
+            <a:spAutoFit/>
+          </a:bodyPr>
+          <a:lstStyle/>
+          <a:p>
+            <a:pPr algn="ctr">
+              <a:defRPr sz="1200" b="1">
+                <a:solidFill>
+                  <a:srgbClr val="FFFFFF"/>
+                </a:solidFill>
+              </a:defRPr>
+            </a:pPr>
+            <a:r>
+              <a:t>Member 2 · XAI &amp; Agronomy Lead</a:t>
+            </a:r>
+          </a:p>
+          <a:p>
+            <a:pPr algn="ctr">
+              <a:defRPr sz="1000">
+                <a:solidFill>
+                  <a:srgbClr val="E6F5EB"/>
+                </a:solidFill>
+              </a:defRPr>
+            </a:pPr>
+            <a:r>
+              <a:t>Explainability &amp; Pathology</a:t>
+            </a:r>
+          </a:p>
+        </p:txBody>
+      </p:sp>
+      <p:sp>
+        <p:nvSpPr>
+          <p:cNvPr id="12" name="TextBox 11"/>
+          <p:cNvSpPr txBox="1"/>
+          <p:nvPr/>
+        </p:nvSpPr>
+        <p:spPr>
+          <a:xfrm>
+            <a:off x="4535424" y="2606040"/>
+            <a:ext cx="3108960" cy="3566160"/>
+          </a:xfrm>
+          <a:prstGeom prst="rect">
+            <a:avLst/>
+          </a:prstGeom>
+          <a:noFill/>
+        </p:spPr>
+        <p:txBody>
+          <a:bodyPr wrap="square">
+            <a:spAutoFit/>
+          </a:bodyPr>
+          <a:lstStyle/>
+          <a:p>
+            <a:pPr>
+              <a:spcBef>
+                <a:spcPts val="600"/>
+              </a:spcBef>
+              <a:defRPr sz="1100">
+                <a:solidFill>
+                  <a:srgbClr val="123726"/>
+                </a:solidFill>
+              </a:defRPr>
+            </a:pPr>
+            <a:r>
+              <a:t>✓ Modules: explainability.py, disease_info.py, evaluate.py</a:t>
+            </a:r>
+          </a:p>
+          <a:p>
+            <a:pPr>
+              <a:spcBef>
+                <a:spcPts val="600"/>
+              </a:spcBef>
+              <a:defRPr sz="1100">
+                <a:solidFill>
+                  <a:srgbClr val="123726"/>
+                </a:solidFill>
+              </a:defRPr>
+            </a:pPr>
+            <a:r>
+              <a:t>✓ Grad-CAM mathematical hooks &amp; gradient backprop implementation</a:t>
+            </a:r>
+          </a:p>
+          <a:p>
+            <a:pPr>
+              <a:spcBef>
+                <a:spcPts val="600"/>
+              </a:spcBef>
+              <a:defRPr sz="1100">
+                <a:solidFill>
+                  <a:srgbClr val="123726"/>
+                </a:solidFill>
+              </a:defRPr>
+            </a:pPr>
+            <a:r>
+              <a:t>✓ Colorized heatmaps (Jet/Turbo), alpha blends, &amp; focus masks</a:t>
+            </a:r>
+          </a:p>
+          <a:p>
+            <a:pPr>
+              <a:spcBef>
+                <a:spcPts val="600"/>
+              </a:spcBef>
+              <a:defRPr sz="1100">
+                <a:solidFill>
+                  <a:srgbClr val="123726"/>
+                </a:solidFill>
+              </a:defRPr>
+            </a:pPr>
+            <a:r>
+              <a:t>✓ Agronomic knowledge base &amp; IPM prescriptions for 10 classes</a:t>
+            </a:r>
+          </a:p>
+          <a:p>
+            <a:pPr>
+              <a:spcBef>
+                <a:spcPts val="600"/>
+              </a:spcBef>
+              <a:defRPr sz="1100">
+                <a:solidFill>
+                  <a:srgbClr val="123726"/>
+                </a:solidFill>
+              </a:defRPr>
+            </a:pPr>
+            <a:r>
+              <a:t>✓ 10×10 Confusion matrix generator &amp; pathology error dynamics</a:t>
+            </a:r>
+          </a:p>
+          <a:p>
+            <a:pPr>
+              <a:spcBef>
+                <a:spcPts val="600"/>
+              </a:spcBef>
+              <a:defRPr sz="1100">
+                <a:solidFill>
+                  <a:srgbClr val="123726"/>
+                </a:solidFill>
+              </a:defRPr>
+            </a:pPr>
+            <a:r>
+              <a:t>✓ Presentation Delivery: Slides 6, 7, 8, 10 (Grad-CAM, Error Analysis, IPM)</a:t>
+            </a:r>
+          </a:p>
+        </p:txBody>
+      </p:sp>
+      <p:sp>
+        <p:nvSpPr>
+          <p:cNvPr id="13" name="Rounded Rectangle 12"/>
+          <p:cNvSpPr/>
+          <p:nvPr/>
+        </p:nvSpPr>
+        <p:spPr>
+          <a:xfrm>
+            <a:off x="8065008" y="1645920"/>
+            <a:ext cx="3383280" cy="4663440"/>
+          </a:xfrm>
+          <a:prstGeom prst="roundRect">
+            <a:avLst/>
+          </a:prstGeom>
+          <a:solidFill>
+            <a:srgbClr val="FFFFFF"/>
+          </a:solidFill>
+          <a:ln w="12700">
+            <a:solidFill>
+              <a:srgbClr val="D7E6DC"/>
+            </a:solidFill>
+          </a:ln>
+        </p:spPr>
+        <p:style>
+          <a:lnRef idx="1">
+            <a:schemeClr val="accent1"/>
+          </a:lnRef>
+          <a:fillRef idx="3">
+            <a:schemeClr val="accent1"/>
+          </a:fillRef>
+          <a:effectRef idx="2">
+            <a:schemeClr val="accent1"/>
+          </a:effectRef>
+          <a:fontRef idx="minor">
+            <a:schemeClr val="lt1"/>
+          </a:fontRef>
+        </p:style>
+        <p:txBody>
+          <a:bodyPr rtlCol="0" anchor="ctr"/>
+          <a:lstStyle/>
+          <a:p>
+            <a:pPr algn="ctr"/>
+          </a:p>
+        </p:txBody>
+      </p:sp>
+      <p:sp>
+        <p:nvSpPr>
+          <p:cNvPr id="14" name="Rounded Rectangle 13"/>
+          <p:cNvSpPr/>
+          <p:nvPr/>
+        </p:nvSpPr>
+        <p:spPr>
+          <a:xfrm>
+            <a:off x="8065008" y="1645920"/>
+            <a:ext cx="3383280" cy="822960"/>
+          </a:xfrm>
+          <a:prstGeom prst="roundRect">
+            <a:avLst/>
+          </a:prstGeom>
+          <a:solidFill>
+            <a:srgbClr val="103324"/>
+          </a:solidFill>
+          <a:ln>
+            <a:noFill/>
+          </a:ln>
+        </p:spPr>
+        <p:style>
+          <a:lnRef idx="1">
+            <a:schemeClr val="accent1"/>
+          </a:lnRef>
+          <a:fillRef idx="3">
+            <a:schemeClr val="accent1"/>
+          </a:fillRef>
+          <a:effectRef idx="2">
+            <a:schemeClr val="accent1"/>
+          </a:effectRef>
+          <a:fontRef idx="minor">
+            <a:schemeClr val="lt1"/>
+          </a:fontRef>
+        </p:style>
+        <p:txBody>
+          <a:bodyPr rtlCol="0" anchor="ctr"/>
+          <a:lstStyle/>
+          <a:p>
+            <a:pPr algn="ctr"/>
+          </a:p>
+        </p:txBody>
+      </p:sp>
+      <p:sp>
+        <p:nvSpPr>
+          <p:cNvPr id="15" name="TextBox 14"/>
+          <p:cNvSpPr txBox="1"/>
+          <p:nvPr/>
+        </p:nvSpPr>
+        <p:spPr>
+          <a:xfrm>
+            <a:off x="8156448" y="1719072"/>
+            <a:ext cx="3200400" cy="365760"/>
+          </a:xfrm>
+          <a:prstGeom prst="rect">
+            <a:avLst/>
+          </a:prstGeom>
+          <a:noFill/>
+        </p:spPr>
+        <p:txBody>
+          <a:bodyPr wrap="none">
+            <a:spAutoFit/>
+          </a:bodyPr>
+          <a:lstStyle/>
+          <a:p>
+            <a:pPr algn="ctr">
+              <a:defRPr sz="1200" b="1">
+                <a:solidFill>
+                  <a:srgbClr val="FFFFFF"/>
+                </a:solidFill>
+              </a:defRPr>
+            </a:pPr>
+            <a:r>
+              <a:t>Member 3 · Full-Stack &amp; MLOps Lead</a:t>
+            </a:r>
+          </a:p>
+          <a:p>
+            <a:pPr algn="ctr">
+              <a:defRPr sz="1000">
+                <a:solidFill>
+                  <a:srgbClr val="E6F5EB"/>
+                </a:solidFill>
+              </a:defRPr>
+            </a:pPr>
+            <a:r>
+              <a:t>UI, Deployment &amp; Testing</a:t>
+            </a:r>
+          </a:p>
+        </p:txBody>
+      </p:sp>
+      <p:sp>
+        <p:nvSpPr>
+          <p:cNvPr id="16" name="TextBox 15"/>
+          <p:cNvSpPr txBox="1"/>
+          <p:nvPr/>
+        </p:nvSpPr>
+        <p:spPr>
+          <a:xfrm>
+            <a:off x="8202168" y="2606040"/>
+            <a:ext cx="3108960" cy="3566160"/>
+          </a:xfrm>
+          <a:prstGeom prst="rect">
+            <a:avLst/>
+          </a:prstGeom>
+          <a:noFill/>
+        </p:spPr>
+        <p:txBody>
+          <a:bodyPr wrap="square">
+            <a:spAutoFit/>
+          </a:bodyPr>
+          <a:lstStyle/>
+          <a:p>
+            <a:pPr>
+              <a:spcBef>
+                <a:spcPts val="600"/>
+              </a:spcBef>
+              <a:defRPr sz="1100">
+                <a:solidFill>
+                  <a:srgbClr val="123726"/>
+                </a:solidFill>
+              </a:defRPr>
+            </a:pPr>
+            <a:r>
+              <a:t>✓ Modules: app.py, predict.py, Dockerfile, tests/test_project.py</a:t>
+            </a:r>
+          </a:p>
+          <a:p>
+            <a:pPr>
+              <a:spcBef>
+                <a:spcPts val="600"/>
+              </a:spcBef>
+              <a:defRPr sz="1100">
+                <a:solidFill>
+                  <a:srgbClr val="123726"/>
+                </a:solidFill>
+              </a:defRPr>
+            </a:pPr>
+            <a:r>
+              <a:t>✓ Interactive Streamlit web app across 4 tabs with smooth CSS animations</a:t>
+            </a:r>
+          </a:p>
+          <a:p>
+            <a:pPr>
+              <a:spcBef>
+                <a:spcPts val="600"/>
+              </a:spcBef>
+              <a:defRPr sz="1100">
+                <a:solidFill>
+                  <a:srgbClr val="123726"/>
+                </a:solidFill>
+              </a:defRPr>
+            </a:pPr>
+            <a:r>
+              <a:t>✓ Standalone CLI inference tool with batch processing &amp; JSON output</a:t>
+            </a:r>
+          </a:p>
+          <a:p>
+            <a:pPr>
+              <a:spcBef>
+                <a:spcPts val="600"/>
+              </a:spcBef>
+              <a:defRPr sz="1100">
+                <a:solidFill>
+                  <a:srgbClr val="123726"/>
+                </a:solidFill>
+              </a:defRPr>
+            </a:pPr>
+            <a:r>
+              <a:t>✓ Comprehensive automated test suite (22 pytest unit &amp; integration tests)</a:t>
+            </a:r>
+          </a:p>
+          <a:p>
+            <a:pPr>
+              <a:spcBef>
+                <a:spcPts val="600"/>
+              </a:spcBef>
+              <a:defRPr sz="1100">
+                <a:solidFill>
+                  <a:srgbClr val="123726"/>
+                </a:solidFill>
+              </a:defRPr>
+            </a:pPr>
+            <a:r>
+              <a:t>✓ Multi-stage Dockerfile, docker-compose, and presentation generation</a:t>
+            </a:r>
+          </a:p>
+          <a:p>
+            <a:pPr>
+              <a:spcBef>
+                <a:spcPts val="600"/>
+              </a:spcBef>
+              <a:defRPr sz="1100">
+                <a:solidFill>
+                  <a:srgbClr val="123726"/>
+                </a:solidFill>
+              </a:defRPr>
+            </a:pPr>
+            <a:r>
+              <a:t>✓ Presentation Delivery: Slides 1, 3, 9, 11, 12, 13 (Intro, Benchmarks, Ops)</a:t>
             </a:r>
           </a:p>
         </p:txBody>

</xml_diff>